<commit_message>
auto: 大轉向簡報週更（pptx+html，市場快照 asof 09/20）[skipreview]
僅自動產出檔（build_final.py 薄轉發器：pptx+html 同步）
</commit_message>
<xml_diff>
--- a/grand_pivot_deck.pptx
+++ b/grand_pivot_deck.pptx
@@ -3171,7 +3171,7 @@
               </a:defRPr>
             </a:pPr>
             <a:r>
-              <a:t>USD/TWD 31.83  ×  台股 45,511（09/15 收盤）  ×  10yr 5.01%</a:t>
+              <a:t>USD/TWD 31.76  ×  台股 47,368（09/20 收盤）  ×  10yr 5.00%</a:t>
             </a:r>
           </a:p>
         </p:txBody>
@@ -3209,7 +3209,7 @@
               </a:defRPr>
             </a:pPr>
             <a:r>
-              <a:t>數據基準：09/15 最新收盤（執行時自動抓取）｜ 龍九控股策略框架 9/6 核准</a:t>
+              <a:t>數據基準：09/20 最新收盤（執行時自動抓取）｜ 龍九控股策略框架 9/6 核准</a:t>
             </a:r>
           </a:p>
           <a:p>
@@ -3370,7 +3370,7 @@
               </a:defRPr>
             </a:pPr>
             <a:r>
-              <a:t>1️⃣ 【您】整池 1,200萬×4.5成 = 540萬@2.77%質押（尚未撥款（對保完成後約 2 週，預估 2026-09-25））</a:t>
+              <a:t>1️⃣ 【您】整池 1,200萬×4.5成 = 540萬@2.77%質押（尚未撥款（對保完成後約 2 週，預估 2026-10-05））</a:t>
             </a:r>
           </a:p>
           <a:p>
@@ -3744,7 +3744,7 @@
               </a:defRPr>
             </a:pPr>
             <a:r>
-              <a:t>💰 匯率 31.83：台幣偏強 → 不再加碼美元曝險，等 10 月重評估</a:t>
+              <a:t>💰 匯率 31.76：台幣偏強 → 不再加碼美元曝險，等 10 月重評估</a:t>
             </a:r>
           </a:p>
           <a:p>
@@ -3798,7 +3798,7 @@
               </a:defRPr>
             </a:pPr>
             <a:r>
-              <a:t>📈 台股 45,511（09/15 收盤，單日 -0.77%）→ 無系統風險，不恐慌不追高</a:t>
+              <a:t>📈 台股 47,368（09/20 收盤，單日 +0.40%）→ 無系統風險，不恐慌不追高</a:t>
             </a:r>
           </a:p>
           <a:p>
@@ -3943,7 +3943,7 @@
               </a:defRPr>
             </a:pPr>
             <a:r>
-              <a:t>即時市場：台股 45,511（-0.77%）</a:t>
+              <a:t>即時市場：台股 47,368（+0.40%）</a:t>
             </a:r>
           </a:p>
         </p:txBody>
@@ -4016,7 +4016,7 @@
               </a:defRPr>
             </a:pPr>
             <a:r>
-              <a:t>📈 台股最新收盤 45,511（單日 -0.77%），asof 09/15</a:t>
+              <a:t>📈 台股最新收盤 47,368（單日 +0.40%），asof 09/20</a:t>
             </a:r>
           </a:p>
           <a:p>
@@ -4058,7 +4058,7 @@
               </a:defRPr>
             </a:pPr>
             <a:r>
-              <a:t>💵 USD/TWD 31.83 — 台幣偏強（較 7/29 高點 32.38 +1.7%）</a:t>
+              <a:t>💵 USD/TWD 31.76 — 台幣偏強（較 7/29 高點 32.38 +1.9%）</a:t>
             </a:r>
           </a:p>
           <a:p>
@@ -4100,7 +4100,7 @@
               </a:defRPr>
             </a:pPr>
             <a:r>
-              <a:t>📡 10yr 5.01% / 30yr 5.38% — 已達 5.30 凍結線，新增質押全域凍結</a:t>
+              <a:t>📡 10yr 5.00% / 30yr 5.33% — 已達 5.30 凍結線，新增質押全域凍結</a:t>
             </a:r>
           </a:p>
           <a:p>
@@ -4176,7 +4176,7 @@
               </a:defRPr>
             </a:pPr>
             <a:r>
-              <a:t>匯率 31.83 — 台幣偏強，美元曝險的雙面刃</a:t>
+              <a:t>匯率 31.76 — 台幣偏強，美元曝險的雙面刃</a:t>
             </a:r>
           </a:p>
         </p:txBody>
@@ -4264,7 +4264,7 @@
               </a:defRPr>
             </a:pPr>
             <a:r>
-              <a:t>     7/29 高點 32.38 → 如今 31.83（台幣偏強 +1.7%）</a:t>
+              <a:t>     7/29 高點 32.38 → 如今 31.76（台幣偏強 +1.9%）</a:t>
             </a:r>
           </a:p>
           <a:p>
@@ -4501,7 +4501,7 @@
               </a:defRPr>
             </a:pPr>
             <a:r>
-              <a:t>證券總市值 2,922,190 元（snapshot 9/4）— 台股 8/24 裁示暫緩、9/6 全面觀望</a:t>
+              <a:t>證券總市值 2,956,130 元（snapshot 9/4）— 台股 8/24 裁示暫緩、9/6 全面觀望</a:t>
             </a:r>
           </a:p>
         </p:txBody>
@@ -4566,112 +4566,112 @@
               </a:defRPr>
             </a:pPr>
             <a:r>
-              <a:t>   0050        214,000  (+26.0%)  元大台灣50</a:t>
-            </a:r>
-          </a:p>
-          <a:p>
-            <a:pPr>
-              <a:spcAft>
-                <a:spcPts val="500"/>
-              </a:spcAft>
-              <a:defRPr sz="1500">
-                <a:solidFill>
-                  <a:srgbClr val="FFFFFF"/>
-                </a:solidFill>
-              </a:defRPr>
-            </a:pPr>
-            <a:r>
-              <a:t>   006208      489,600  (+24.3%)  富邦台50</a:t>
-            </a:r>
-          </a:p>
-          <a:p>
-            <a:pPr>
-              <a:spcAft>
-                <a:spcPts val="500"/>
-              </a:spcAft>
-              <a:defRPr sz="1500">
-                <a:solidFill>
-                  <a:srgbClr val="FFFFFF"/>
-                </a:solidFill>
-              </a:defRPr>
-            </a:pPr>
-            <a:r>
-              <a:t>   009816      253,760  (+27.0%)  凱基台灣TOP50</a:t>
-            </a:r>
-          </a:p>
-          <a:p>
-            <a:pPr>
-              <a:spcAft>
-                <a:spcPts val="500"/>
-              </a:spcAft>
-              <a:defRPr sz="1500">
-                <a:solidFill>
-                  <a:srgbClr val="FFFFFF"/>
-                </a:solidFill>
-              </a:defRPr>
-            </a:pPr>
-            <a:r>
-              <a:t>   00646        76,150  (+6.3%)  元大S&amp;P500</a:t>
-            </a:r>
-          </a:p>
-          <a:p>
-            <a:pPr>
-              <a:spcAft>
-                <a:spcPts val="500"/>
-              </a:spcAft>
-              <a:defRPr sz="1500">
-                <a:solidFill>
-                  <a:srgbClr val="FFFFFF"/>
-                </a:solidFill>
-              </a:defRPr>
-            </a:pPr>
-            <a:r>
-              <a:t>   00713       128,700  (+17.4%)  元大台灣高息低波</a:t>
-            </a:r>
-          </a:p>
-          <a:p>
-            <a:pPr>
-              <a:spcAft>
-                <a:spcPts val="500"/>
-              </a:spcAft>
-              <a:defRPr sz="1500">
-                <a:solidFill>
-                  <a:srgbClr val="FFFFFF"/>
-                </a:solidFill>
-              </a:defRPr>
-            </a:pPr>
-            <a:r>
-              <a:t>   00878       514,500  (+26.2%)  國泰永續高股息</a:t>
-            </a:r>
-          </a:p>
-          <a:p>
-            <a:pPr>
-              <a:spcAft>
-                <a:spcPts val="500"/>
-              </a:spcAft>
-              <a:defRPr sz="1500">
-                <a:solidFill>
-                  <a:srgbClr val="FFFFFF"/>
-                </a:solidFill>
-              </a:defRPr>
-            </a:pPr>
-            <a:r>
-              <a:t>   0056         55,500  (+49.4%)  元大高股息</a:t>
-            </a:r>
-          </a:p>
-          <a:p>
-            <a:pPr>
-              <a:spcAft>
-                <a:spcPts val="500"/>
-              </a:spcAft>
-              <a:defRPr sz="1500">
-                <a:solidFill>
-                  <a:srgbClr val="FFFFFF"/>
-                </a:solidFill>
-              </a:defRPr>
-            </a:pPr>
-            <a:r>
-              <a:t>   00981A      235,040  (+11.6%)  統一台灣高息動能</a:t>
+              <a:t>   0050        218,500  (+28.7%)  元大台灣50</a:t>
+            </a:r>
+          </a:p>
+          <a:p>
+            <a:pPr>
+              <a:spcAft>
+                <a:spcPts val="500"/>
+              </a:spcAft>
+              <a:defRPr sz="1500">
+                <a:solidFill>
+                  <a:srgbClr val="FFFFFF"/>
+                </a:solidFill>
+              </a:defRPr>
+            </a:pPr>
+            <a:r>
+              <a:t>   006208      500,800  (+27.2%)  富邦台50</a:t>
+            </a:r>
+          </a:p>
+          <a:p>
+            <a:pPr>
+              <a:spcAft>
+                <a:spcPts val="500"/>
+              </a:spcAft>
+              <a:defRPr sz="1500">
+                <a:solidFill>
+                  <a:srgbClr val="FFFFFF"/>
+                </a:solidFill>
+              </a:defRPr>
+            </a:pPr>
+            <a:r>
+              <a:t>   009816      259,040  (+29.6%)  凱基台灣TOP50</a:t>
+            </a:r>
+          </a:p>
+          <a:p>
+            <a:pPr>
+              <a:spcAft>
+                <a:spcPts val="500"/>
+              </a:spcAft>
+              <a:defRPr sz="1500">
+                <a:solidFill>
+                  <a:srgbClr val="FFFFFF"/>
+                </a:solidFill>
+              </a:defRPr>
+            </a:pPr>
+            <a:r>
+              <a:t>   00646        76,600  (+7.0%)  元大S&amp;P500</a:t>
+            </a:r>
+          </a:p>
+          <a:p>
+            <a:pPr>
+              <a:spcAft>
+                <a:spcPts val="500"/>
+              </a:spcAft>
+              <a:defRPr sz="1500">
+                <a:solidFill>
+                  <a:srgbClr val="FFFFFF"/>
+                </a:solidFill>
+              </a:defRPr>
+            </a:pPr>
+            <a:r>
+              <a:t>   00713       130,100  (+18.7%)  元大台灣高息低波</a:t>
+            </a:r>
+          </a:p>
+          <a:p>
+            <a:pPr>
+              <a:spcAft>
+                <a:spcPts val="500"/>
+              </a:spcAft>
+              <a:defRPr sz="1500">
+                <a:solidFill>
+                  <a:srgbClr val="FFFFFF"/>
+                </a:solidFill>
+              </a:defRPr>
+            </a:pPr>
+            <a:r>
+              <a:t>   00878       523,650  (+28.5%)  國泰永續高股息</a:t>
+            </a:r>
+          </a:p>
+          <a:p>
+            <a:pPr>
+              <a:spcAft>
+                <a:spcPts val="500"/>
+              </a:spcAft>
+              <a:defRPr sz="1500">
+                <a:solidFill>
+                  <a:srgbClr val="FFFFFF"/>
+                </a:solidFill>
+              </a:defRPr>
+            </a:pPr>
+            <a:r>
+              <a:t>   0056         56,850  (+53.0%)  元大高股息</a:t>
+            </a:r>
+          </a:p>
+          <a:p>
+            <a:pPr>
+              <a:spcAft>
+                <a:spcPts val="500"/>
+              </a:spcAft>
+              <a:defRPr sz="1500">
+                <a:solidFill>
+                  <a:srgbClr val="FFFFFF"/>
+                </a:solidFill>
+              </a:defRPr>
+            </a:pPr>
+            <a:r>
+              <a:t>   00981A      230,640  (+9.5%)  主動統一台灣成長</a:t>
             </a:r>
           </a:p>
           <a:p>
@@ -4866,7 +4866,7 @@
               </a:defRPr>
             </a:pPr>
             <a:r>
-              <a:t>基金總市值 12,628,144 元（snapshot 9/4 報價日 9/3）</a:t>
+              <a:t>基金總市值 12,669,739 元（snapshot 9/4 報價日 9/3）</a:t>
             </a:r>
           </a:p>
         </p:txBody>
@@ -4919,37 +4919,37 @@
               </a:defRPr>
             </a:pPr>
             <a:r>
-              <a:t>     富達全球動能B月配美元 5,853,439 元 — 月配息主力</a:t>
-            </a:r>
-          </a:p>
-          <a:p>
-            <a:pPr>
-              <a:spcAft>
-                <a:spcPts val="500"/>
-              </a:spcAft>
-              <a:defRPr sz="1500">
-                <a:solidFill>
-                  <a:srgbClr val="FFFFFF"/>
-                </a:solidFill>
-              </a:defRPr>
-            </a:pPr>
-            <a:r>
-              <a:t>     貝萊德B11 強化穩定月配息 4,981,060 元（原 MMF 500 萬贖回款轉申購；⛔ 原「500萬標案預備金」已作廢 9/11）</a:t>
-            </a:r>
-          </a:p>
-          <a:p>
-            <a:pPr>
-              <a:spcAft>
-                <a:spcPts val="500"/>
-              </a:spcAft>
-              <a:defRPr sz="1500">
-                <a:solidFill>
-                  <a:srgbClr val="FFFFFF"/>
-                </a:solidFill>
-              </a:defRPr>
-            </a:pPr>
-            <a:r>
-              <a:t>     聯博全球多元收益AD美元月配 971,483 元</a:t>
+              <a:t>     富達全球動能B月配美元 5,877,925 元 — 月配息主力</a:t>
+            </a:r>
+          </a:p>
+          <a:p>
+            <a:pPr>
+              <a:spcAft>
+                <a:spcPts val="500"/>
+              </a:spcAft>
+              <a:defRPr sz="1500">
+                <a:solidFill>
+                  <a:srgbClr val="FFFFFF"/>
+                </a:solidFill>
+              </a:defRPr>
+            </a:pPr>
+            <a:r>
+              <a:t>     貝萊德B11 強化穩定月配息 4,999,218 元（原 MMF 500 萬贖回款轉申購；⛔ 原「500萬標案預備金」已作廢 9/11）</a:t>
+            </a:r>
+          </a:p>
+          <a:p>
+            <a:pPr>
+              <a:spcAft>
+                <a:spcPts val="500"/>
+              </a:spcAft>
+              <a:defRPr sz="1500">
+                <a:solidFill>
+                  <a:srgbClr val="FFFFFF"/>
+                </a:solidFill>
+              </a:defRPr>
+            </a:pPr>
+            <a:r>
+              <a:t>     聯博全球多元收益AD美元月配 978,870 元</a:t>
             </a:r>
           </a:p>
           <a:p>
@@ -5416,7 +5416,7 @@
               </a:defRPr>
             </a:pPr>
             <a:r>
-              <a:t>穿透：台股 7.5%｜美股 40.6%（科技15.4）｜防守配息 17.4%｜債券 27.6%｜現金 3.4%</a:t>
+              <a:t>穿透：台股 7.5%｜美股 39.4%（科技15.2）｜防守配息 17.4%｜債券 28.8%｜現金 3.5%</a:t>
             </a:r>
           </a:p>
         </p:txBody>
@@ -5595,7 +5595,7 @@
               </a:defRPr>
             </a:pPr>
             <a:r>
-              <a:t>📊 現金/安全網穿透 3.4%：底線 70 萬已守住</a:t>
+              <a:t>📊 現金/安全網穿透 3.5%：底線 70 萬已守住</a:t>
             </a:r>
           </a:p>
           <a:p>
@@ -5744,7 +5744,7 @@
               </a:defRPr>
             </a:pPr>
             <a:r>
-              <a:t>🔴 情境A：升息（30yr 5.38% 警戒區，CPI 9/11 關鍵）</a:t>
+              <a:t>🔴 情境A：升息（30yr 5.33% 警戒區，CPI 9/11 關鍵）</a:t>
             </a:r>
           </a:p>
           <a:p>
@@ -6019,7 +6019,7 @@
               </a:defRPr>
             </a:pPr>
             <a:r>
-              <a:t>📅 質押：🔍 質押：擔保池 1,200萬（富達600＋聯博100＋貝萊德B11 500）×4.5成 = 540萬@2.77%；尚未撥款（對保完成後約 2 週，預估 2026-09-25） → 用途：優先清償 500萬高息負債（保單質押 400萬@4.0% ＋ 券商質押 100萬@3.92%）— 月息 16,600 → 12,465，月省約 4,135（2026-09-12 裁示；10月標案押標金不預留，9月底評估）</a:t>
+              <a:t>📅 質押：🔍 質押：擔保池 1,200萬（富達600＋聯博100＋貝萊德B11 500）×4.5成 = 540萬@2.77%；尚未撥款（對保完成後約 2 週，預估 2026-10-05） → 用途：優先清償 500萬高息負債（保單質押 400萬@4.0% ＋ 券商質押 100萬@3.92%）— 月息 16,600 → 12,465，月省約 4,135（2026-09-12 裁示；10月標案押標金不預留，9月底評估）</a:t>
             </a:r>
           </a:p>
           <a:p>

</xml_diff>

<commit_message>
publish(deck): 大轉向簡報 v5（asof 10/08）＋ pptx 上線
來源：週日 17:00 job（build_final.py，no_agent 零 LLM）已產出但未推送；
線上按鈕仍指 10-04 舊版。本次以既有資料通道（RECORD）補發布，未改程式。
</commit_message>
<xml_diff>
--- a/grand_pivot_deck.pptx
+++ b/grand_pivot_deck.pptx
@@ -3209,7 +3209,7 @@
               </a:defRPr>
             </a:pPr>
             <a:r>
-              <a:t>數據基準：10/06 最新收盤（執行時自動抓取）｜ 龍九控股策略框架 9/6 核准</a:t>
+              <a:t>數據基準：10/08 最新收盤（執行時自動抓取）｜ 龍九控股策略框架 9/6 核准</a:t>
             </a:r>
           </a:p>
           <a:p>
@@ -3798,7 +3798,7 @@
               </a:defRPr>
             </a:pPr>
             <a:r>
-              <a:t>📈 台股 49,712（10/06 收盤，單日 +2.55%）→ 無系統風險，不恐慌不追高</a:t>
+              <a:t>📈 台股 49,313（10/08 收盤，單日 -0.99%）→ 無系統風險，不恐慌不追高</a:t>
             </a:r>
           </a:p>
           <a:p>
@@ -3943,7 +3943,7 @@
               </a:defRPr>
             </a:pPr>
             <a:r>
-              <a:t>即時市場：台股 49,712（+2.55%）</a:t>
+              <a:t>即時市場：台股 49,313（-0.99%）</a:t>
             </a:r>
           </a:p>
         </p:txBody>
@@ -4016,7 +4016,7 @@
               </a:defRPr>
             </a:pPr>
             <a:r>
-              <a:t>📈 台股最新收盤 49,712（單日 +2.55%），asof 10/06</a:t>
+              <a:t>📈 台股最新收盤 49,313（單日 -0.99%），asof 10/08</a:t>
             </a:r>
           </a:p>
           <a:p>
@@ -4100,7 +4100,7 @@
               </a:defRPr>
             </a:pPr>
             <a:r>
-              <a:t>📡 10yr 5.27% / 30yr 5.64% — 已達 5.30 凍結線，新增質押全域凍結</a:t>
+              <a:t>📡 10yr 5.24% / 30yr 5.60% — 已達 5.30 凍結線，新增質押全域凍結</a:t>
             </a:r>
           </a:p>
           <a:p>
@@ -4176,7 +4176,7 @@
               </a:defRPr>
             </a:pPr>
             <a:r>
-              <a:t>匯率 31.78 — 台幣偏強</a:t>
+              <a:t>匯率 31.92 — 台幣偏強</a:t>
             </a:r>
           </a:p>
         </p:txBody>
@@ -4211,7 +4211,7 @@
               </a:defRPr>
             </a:pPr>
             <a:r>
-              <a:t>美元曝險 70.5%（🟡 僅顯示，門檻 60；政策門檻待 10 月戰略檢討）</a:t>
+              <a:t>美元曝險 71.4%（🟡 僅顯示，門檻 60；政策門檻待 10 月戰略檢討）</a:t>
             </a:r>
           </a:p>
         </p:txBody>
@@ -4264,7 +4264,7 @@
               </a:defRPr>
             </a:pPr>
             <a:r>
-              <a:t>     7/29 高點 32.38 → 如今 31.78（台幣偏強 +1.9%）</a:t>
+              <a:t>     7/29 高點 32.38 → 如今 31.92（台幣偏強 +1.4%）</a:t>
             </a:r>
           </a:p>
           <a:p>
@@ -4501,7 +4501,7 @@
               </a:defRPr>
             </a:pPr>
             <a:r>
-              <a:t>證券總市值 3,064,250 元（snapshot 9/4）— 台股 8/24 裁示暫緩、9/6 全面觀望</a:t>
+              <a:t>證券總市值 3,045,250 元（snapshot 9/4）— 台股 8/24 裁示暫緩、9/6 全面觀望</a:t>
             </a:r>
           </a:p>
         </p:txBody>
@@ -4566,112 +4566,112 @@
               </a:defRPr>
             </a:pPr>
             <a:r>
-              <a:t>   0050        233,000  (+37.2%)  元大台灣50</a:t>
-            </a:r>
-          </a:p>
-          <a:p>
-            <a:pPr>
-              <a:spcAft>
-                <a:spcPts val="500"/>
-              </a:spcAft>
-              <a:defRPr sz="1500">
-                <a:solidFill>
-                  <a:srgbClr val="FFFFFF"/>
-                </a:solidFill>
-              </a:defRPr>
-            </a:pPr>
-            <a:r>
-              <a:t>   006208      531,800  (+35.0%)  富邦台50</a:t>
-            </a:r>
-          </a:p>
-          <a:p>
-            <a:pPr>
-              <a:spcAft>
-                <a:spcPts val="500"/>
-              </a:spcAft>
-              <a:defRPr sz="1500">
-                <a:solidFill>
-                  <a:srgbClr val="FFFFFF"/>
-                </a:solidFill>
-              </a:defRPr>
-            </a:pPr>
-            <a:r>
-              <a:t>   009816      272,960  (+36.6%)  凱基台灣TOP50</a:t>
-            </a:r>
-          </a:p>
-          <a:p>
-            <a:pPr>
-              <a:spcAft>
-                <a:spcPts val="500"/>
-              </a:spcAft>
-              <a:defRPr sz="1500">
-                <a:solidFill>
-                  <a:srgbClr val="FFFFFF"/>
-                </a:solidFill>
-              </a:defRPr>
-            </a:pPr>
-            <a:r>
-              <a:t>   00646        77,850  (+8.7%)  元大S&amp;P500</a:t>
-            </a:r>
-          </a:p>
-          <a:p>
-            <a:pPr>
-              <a:spcAft>
-                <a:spcPts val="500"/>
-              </a:spcAft>
-              <a:defRPr sz="1500">
-                <a:solidFill>
-                  <a:srgbClr val="FFFFFF"/>
-                </a:solidFill>
-              </a:defRPr>
-            </a:pPr>
-            <a:r>
-              <a:t>   00713       125,900  (+14.9%)  元大台灣高息低波</a:t>
-            </a:r>
-          </a:p>
-          <a:p>
-            <a:pPr>
-              <a:spcAft>
-                <a:spcPts val="500"/>
-              </a:spcAft>
-              <a:defRPr sz="1500">
-                <a:solidFill>
-                  <a:srgbClr val="FFFFFF"/>
-                </a:solidFill>
-              </a:defRPr>
-            </a:pPr>
-            <a:r>
-              <a:t>   00878       527,550  (+29.4%)  國泰永續高股息</a:t>
-            </a:r>
-          </a:p>
-          <a:p>
-            <a:pPr>
-              <a:spcAft>
-                <a:spcPts val="500"/>
-              </a:spcAft>
-              <a:defRPr sz="1500">
-                <a:solidFill>
-                  <a:srgbClr val="FFFFFF"/>
-                </a:solidFill>
-              </a:defRPr>
-            </a:pPr>
-            <a:r>
-              <a:t>   0056         58,100  (+56.4%)  元大高股息</a:t>
-            </a:r>
-          </a:p>
-          <a:p>
-            <a:pPr>
-              <a:spcAft>
-                <a:spcPts val="500"/>
-              </a:spcAft>
-              <a:defRPr sz="1500">
-                <a:solidFill>
-                  <a:srgbClr val="FFFFFF"/>
-                </a:solidFill>
-              </a:defRPr>
-            </a:pPr>
-            <a:r>
-              <a:t>   00981A      260,800  (+23.9%)  主動統一台灣增長</a:t>
+              <a:t>   0050        230,200  (+35.6%)  元大台灣50</a:t>
+            </a:r>
+          </a:p>
+          <a:p>
+            <a:pPr>
+              <a:spcAft>
+                <a:spcPts val="500"/>
+              </a:spcAft>
+              <a:defRPr sz="1500">
+                <a:solidFill>
+                  <a:srgbClr val="FFFFFF"/>
+                </a:solidFill>
+              </a:defRPr>
+            </a:pPr>
+            <a:r>
+              <a:t>   006208      526,500  (+33.7%)  富邦台50</a:t>
+            </a:r>
+          </a:p>
+          <a:p>
+            <a:pPr>
+              <a:spcAft>
+                <a:spcPts val="500"/>
+              </a:spcAft>
+              <a:defRPr sz="1500">
+                <a:solidFill>
+                  <a:srgbClr val="FFFFFF"/>
+                </a:solidFill>
+              </a:defRPr>
+            </a:pPr>
+            <a:r>
+              <a:t>   009816      270,400  (+35.3%)  凱基台灣TOP50</a:t>
+            </a:r>
+          </a:p>
+          <a:p>
+            <a:pPr>
+              <a:spcAft>
+                <a:spcPts val="500"/>
+              </a:spcAft>
+              <a:defRPr sz="1500">
+                <a:solidFill>
+                  <a:srgbClr val="FFFFFF"/>
+                </a:solidFill>
+              </a:defRPr>
+            </a:pPr>
+            <a:r>
+              <a:t>   00646        78,050  (+9.0%)  元大S&amp;P500</a:t>
+            </a:r>
+          </a:p>
+          <a:p>
+            <a:pPr>
+              <a:spcAft>
+                <a:spcPts val="500"/>
+              </a:spcAft>
+              <a:defRPr sz="1500">
+                <a:solidFill>
+                  <a:srgbClr val="FFFFFF"/>
+                </a:solidFill>
+              </a:defRPr>
+            </a:pPr>
+            <a:r>
+              <a:t>   00713       126,400  (+15.3%)  元大台灣高息低波</a:t>
+            </a:r>
+          </a:p>
+          <a:p>
+            <a:pPr>
+              <a:spcAft>
+                <a:spcPts val="500"/>
+              </a:spcAft>
+              <a:defRPr sz="1500">
+                <a:solidFill>
+                  <a:srgbClr val="FFFFFF"/>
+                </a:solidFill>
+              </a:defRPr>
+            </a:pPr>
+            <a:r>
+              <a:t>   00878       525,150  (+28.9%)  國泰永續高股息</a:t>
+            </a:r>
+          </a:p>
+          <a:p>
+            <a:pPr>
+              <a:spcAft>
+                <a:spcPts val="500"/>
+              </a:spcAft>
+              <a:defRPr sz="1500">
+                <a:solidFill>
+                  <a:srgbClr val="FFFFFF"/>
+                </a:solidFill>
+              </a:defRPr>
+            </a:pPr>
+            <a:r>
+              <a:t>   0056         58,200  (+56.7%)  元大高股息</a:t>
+            </a:r>
+          </a:p>
+          <a:p>
+            <a:pPr>
+              <a:spcAft>
+                <a:spcPts val="500"/>
+              </a:spcAft>
+              <a:defRPr sz="1500">
+                <a:solidFill>
+                  <a:srgbClr val="FFFFFF"/>
+                </a:solidFill>
+              </a:defRPr>
+            </a:pPr>
+            <a:r>
+              <a:t>   00981A      255,120  (+21.2%)  主動統一台灣增長</a:t>
             </a:r>
           </a:p>
           <a:p>
@@ -4866,7 +4866,7 @@
               </a:defRPr>
             </a:pPr>
             <a:r>
-              <a:t>基金總市值 12,522,002 元（snapshot 9/4 報價日 9/3）</a:t>
+              <a:t>基金總市值 12,693,106 元（snapshot 9/4 報價日 9/3）</a:t>
             </a:r>
           </a:p>
         </p:txBody>
@@ -4934,22 +4934,22 @@
               </a:defRPr>
             </a:pPr>
             <a:r>
-              <a:t>     貝萊德B11 強化穩定月配息 4,882,121 元（原 MMF 500 萬贖回款轉申購；⛔ 原「500萬標案預備金」已作廢 9/11）</a:t>
-            </a:r>
-          </a:p>
-          <a:p>
-            <a:pPr>
-              <a:spcAft>
-                <a:spcPts val="500"/>
-              </a:spcAft>
-              <a:defRPr sz="1500">
-                <a:solidFill>
-                  <a:srgbClr val="FFFFFF"/>
-                </a:solidFill>
-              </a:defRPr>
-            </a:pPr>
-            <a:r>
-              <a:t>     聯博全球多元收益AD美元月配 963,376 元</a:t>
+              <a:t>     貝萊德B11 強化穩定月配息 4,922,710 元（原 MMF 500 萬贖回款轉申購；⛔ 原「500萬標案預備金」已作廢 9/11）</a:t>
+            </a:r>
+          </a:p>
+          <a:p>
+            <a:pPr>
+              <a:spcAft>
+                <a:spcPts val="500"/>
+              </a:spcAft>
+              <a:defRPr sz="1500">
+                <a:solidFill>
+                  <a:srgbClr val="FFFFFF"/>
+                </a:solidFill>
+              </a:defRPr>
+            </a:pPr>
+            <a:r>
+              <a:t>     聯博全球多元收益AD美元月配 968,889 元</a:t>
             </a:r>
           </a:p>
           <a:p>
@@ -5401,7 +5401,7 @@
               </a:defRPr>
             </a:pPr>
             <a:r>
-              <a:t>穿透：台股 7.9%｜美股 37.5%（科技14.9）｜防守配息 18.1%｜債券 26.7%｜現金 3.3%</a:t>
+              <a:t>穿透：台股 7.8%｜美股 38.1%（科技15.1）｜防守配息 18.2%｜債券 26.9%｜現金 2.4%</a:t>
             </a:r>
           </a:p>
         </p:txBody>
@@ -5469,7 +5469,7 @@
               </a:defRPr>
             </a:pPr>
             <a:r>
-              <a:t>     台股穿透 7.9% → 偏低，但觀望期凍結新增</a:t>
+              <a:t>     台股穿透 7.8% → 偏低，但觀望期凍結新增</a:t>
             </a:r>
           </a:p>
           <a:p>
@@ -5580,7 +5580,7 @@
               </a:defRPr>
             </a:pPr>
             <a:r>
-              <a:t>📊 現金/安全網穿透 3.3%：底線 70 萬已守住</a:t>
+              <a:t>📊 現金/安全網穿透 2.4%：底線 70 萬已守住</a:t>
             </a:r>
           </a:p>
           <a:p>
@@ -5729,7 +5729,7 @@
               </a:defRPr>
             </a:pPr>
             <a:r>
-              <a:t>🔴 情境A：升息（30yr 5.64% 警戒區，CPI 9/11 關鍵）</a:t>
+              <a:t>🔴 情境A：升息（30yr 5.60% 警戒區，CPI 9/11 關鍵）</a:t>
             </a:r>
           </a:p>
           <a:p>

</xml_diff>